<commit_message>
Vendor the engine's type scale: PDF and pptx set text as large on the slide as HTML does
Vendors beamer-livery-theme #28 (livery.json `type`: HTML's sizes as fractions of the slide
height, which beamer and the pptx templates now follow) and regenerates cu's and nsi's
build/ and templates; cu drops its 20/18/16/14/12 body-sizes-pt.

The framework's own sizes follow the same table (livery.type_pt): style_footnotes.py's
footnotes and slide_layout.py's full-figure captions at the footnote and caption roles (were
13 pt), the cover feature's title and body at the slide-title and body roles; style_tables.py
pads cells as HTML's rows (0.4 of the table size above and below). CLAUDE.md's note on the
master's body sizes says where they come from now.

Co-Authored-By: Claude Opus 5.5 <noreply@anthropic.com>
Claude-Session: https://claude.ai/code/session_01QxTZPtUJESWqMyXE15JCRv
</commit_message>
<xml_diff>
--- a/docs/common/_extensions/benkirk/engine/liveries/ncar/template.pptx
+++ b/docs/common/_extensions/benkirk/engine/liveries/ncar/template.pptx
@@ -362,7 +362,7 @@
                 <a:spcPts val="0"/>
               </a:spcBef>
               <a:buNone/>
-              <a:defRPr sz="1200" b="1" cap="all">
+              <a:defRPr sz="1008" b="1" cap="all">
                 <a:solidFill>
                   <a:srgbClr val="FFFFFF"/>
                 </a:solidFill>
@@ -407,7 +407,7 @@
                 <a:spcPts val="0"/>
               </a:spcBef>
               <a:buNone/>
-              <a:defRPr sz="3600" b="1">
+              <a:defRPr sz="3863" b="1">
                 <a:solidFill>
                   <a:srgbClr val="FFFFFF"/>
                 </a:solidFill>
@@ -473,7 +473,7 @@
                 <a:spcPts val="0"/>
               </a:spcBef>
               <a:buNone/>
-              <a:defRPr sz="1800" b="0">
+              <a:defRPr sz="1679" b="0">
                 <a:solidFill>
                   <a:srgbClr val="FFFFFF"/>
                 </a:solidFill>
@@ -798,7 +798,7 @@
               <a:lnSpc>
                 <a:spcPct val="90000"/>
               </a:lnSpc>
-              <a:defRPr sz="4400" b="1">
+              <a:defRPr sz="4366" b="1">
                 <a:solidFill>
                   <a:srgbClr val="00357A"/>
                 </a:solidFill>
@@ -839,21 +839,21 @@
           </a:bodyPr>
           <a:lstStyle>
             <a:lvl1pPr>
-              <a:defRPr sz="2000">
+              <a:defRPr sz="1679">
                 <a:solidFill>
                   <a:srgbClr val="00357A"/>
                 </a:solidFill>
               </a:defRPr>
             </a:lvl1pPr>
             <a:lvl2pPr>
-              <a:defRPr sz="1800">
+              <a:defRPr sz="1511">
                 <a:solidFill>
                   <a:srgbClr val="00357A"/>
                 </a:solidFill>
               </a:defRPr>
             </a:lvl2pPr>
             <a:lvl3pPr>
-              <a:defRPr sz="1600">
+              <a:defRPr sz="1360">
                 <a:solidFill>
                   <a:srgbClr val="00357A"/>
                 </a:solidFill>
@@ -1503,7 +1503,7 @@
               <a:lnSpc>
                 <a:spcPct val="90000"/>
               </a:lnSpc>
-              <a:defRPr sz="4400" b="1" cap="none" baseline="0">
+              <a:defRPr sz="4366" b="1" cap="none" baseline="0">
                 <a:solidFill>
                   <a:srgbClr val="FFFFFF"/>
                 </a:solidFill>
@@ -1548,7 +1548,7 @@
                 <a:spcPts val="0"/>
               </a:spcBef>
               <a:buNone/>
-              <a:defRPr sz="1800" b="0">
+              <a:defRPr sz="1847" b="0">
                 <a:solidFill>
                   <a:srgbClr val="FFFFFF"/>
                 </a:solidFill>
@@ -1974,7 +1974,7 @@
           <a:lstStyle>
             <a:lvl1pPr marL="0" indent="0">
               <a:buNone/>
-              <a:defRPr sz="1800" b="1">
+              <a:defRPr sz="1847" b="1">
                 <a:solidFill>
                   <a:schemeClr val="tx2"/>
                 </a:solidFill>
@@ -2045,7 +2045,7 @@
           <a:lstStyle>
             <a:lvl1pPr marL="0" indent="0">
               <a:buNone/>
-              <a:defRPr sz="1800" b="1">
+              <a:defRPr sz="1847" b="1">
                 <a:solidFill>
                   <a:schemeClr val="tx2"/>
                 </a:solidFill>
@@ -2251,7 +2251,7 @@
           </a:bodyPr>
           <a:lstStyle>
             <a:lvl1pPr algn="l">
-              <a:defRPr sz="2000" b="1"/>
+              <a:defRPr sz="1847" b="1"/>
             </a:lvl1pPr>
           </a:lstStyle>
           <a:p>
@@ -2318,7 +2318,7 @@
           <a:lstStyle>
             <a:lvl1pPr marL="0" indent="0">
               <a:buNone/>
-              <a:defRPr sz="1400"/>
+              <a:defRPr sz="1427"/>
             </a:lvl1pPr>
           </a:lstStyle>
           <a:p>
@@ -2930,7 +2930,7 @@
               <a:lnSpc>
                 <a:spcPct val="90000"/>
               </a:lnSpc>
-              <a:defRPr sz="4400" b="1">
+              <a:defRPr sz="4366" b="1">
                 <a:solidFill>
                   <a:srgbClr val="FFFFFF"/>
                 </a:solidFill>
@@ -2971,21 +2971,21 @@
           </a:bodyPr>
           <a:lstStyle>
             <a:lvl1pPr>
-              <a:defRPr sz="2000">
+              <a:defRPr sz="1679">
                 <a:solidFill>
                   <a:srgbClr val="FFFFFF"/>
                 </a:solidFill>
               </a:defRPr>
             </a:lvl1pPr>
             <a:lvl2pPr>
-              <a:defRPr sz="1800">
+              <a:defRPr sz="1511">
                 <a:solidFill>
                   <a:srgbClr val="FFFFFF"/>
                 </a:solidFill>
               </a:defRPr>
             </a:lvl2pPr>
             <a:lvl3pPr>
-              <a:defRPr sz="1600">
+              <a:defRPr sz="1360">
                 <a:solidFill>
                   <a:srgbClr val="FFFFFF"/>
                 </a:solidFill>
@@ -3348,7 +3348,7 @@
                 <a:spcPts val="0"/>
               </a:spcBef>
               <a:buNone/>
-              <a:defRPr sz="1200" b="1" cap="all">
+              <a:defRPr sz="1008" b="1" cap="all">
                 <a:solidFill>
                   <a:srgbClr val="00357A"/>
                 </a:solidFill>
@@ -3393,7 +3393,7 @@
                 <a:spcPts val="0"/>
               </a:spcBef>
               <a:buNone/>
-              <a:defRPr sz="3600" b="1">
+              <a:defRPr sz="3863" b="1">
                 <a:solidFill>
                   <a:srgbClr val="00357A"/>
                 </a:solidFill>
@@ -3459,7 +3459,7 @@
                 <a:spcPts val="0"/>
               </a:spcBef>
               <a:buNone/>
-              <a:defRPr sz="1800" b="0">
+              <a:defRPr sz="1679" b="0">
                 <a:solidFill>
                   <a:srgbClr val="00357A"/>
                 </a:solidFill>
@@ -3974,7 +3974,7 @@
           <a:spcPct val="0"/>
         </a:spcBef>
         <a:buNone/>
-        <a:defRPr sz="2800" b="1" kern="1200" baseline="0">
+        <a:defRPr sz="2759" b="1" kern="1200" baseline="0">
           <a:solidFill>
             <a:schemeClr val="tx1"/>
           </a:solidFill>
@@ -3990,11 +3990,11 @@
           <a:spcPct val="100000"/>
         </a:lnSpc>
         <a:spcBef>
-          <a:spcPts val="1000"/>
+          <a:spcPts val="840"/>
         </a:spcBef>
         <a:buFont typeface="Arial"/>
         <a:buChar char="•"/>
-        <a:defRPr sz="2000" kern="1200">
+        <a:defRPr sz="1679" kern="1200">
           <a:solidFill>
             <a:schemeClr val="tx1"/>
           </a:solidFill>
@@ -4008,11 +4008,11 @@
           <a:spcPct val="100000"/>
         </a:lnSpc>
         <a:spcBef>
-          <a:spcPts val="500"/>
+          <a:spcPts val="504"/>
         </a:spcBef>
         <a:buFont typeface="Wingdings"/>
         <a:buChar char="§"/>
-        <a:defRPr sz="1800" kern="1200">
+        <a:defRPr sz="1511" kern="1200">
           <a:solidFill>
             <a:schemeClr val="tx1"/>
           </a:solidFill>
@@ -4026,11 +4026,11 @@
           <a:spcPct val="100000"/>
         </a:lnSpc>
         <a:spcBef>
-          <a:spcPts val="500"/>
+          <a:spcPts val="504"/>
         </a:spcBef>
         <a:buFont typeface="Courier New"/>
         <a:buChar char="o"/>
-        <a:defRPr sz="1600" kern="1200">
+        <a:defRPr sz="1360" kern="1200">
           <a:solidFill>
             <a:schemeClr val="tx1"/>
           </a:solidFill>
@@ -4044,11 +4044,11 @@
           <a:spcPct val="100000"/>
         </a:lnSpc>
         <a:spcBef>
-          <a:spcPts val="500"/>
+          <a:spcPts val="504"/>
         </a:spcBef>
         <a:buFont typeface="Arial"/>
         <a:buChar char="–"/>
-        <a:defRPr sz="1400" kern="1200">
+        <a:defRPr sz="1224" kern="1200">
           <a:solidFill>
             <a:schemeClr val="tx1"/>
           </a:solidFill>
@@ -4062,11 +4062,11 @@
           <a:spcPct val="100000"/>
         </a:lnSpc>
         <a:spcBef>
-          <a:spcPts val="500"/>
+          <a:spcPts val="504"/>
         </a:spcBef>
         <a:buFont typeface="Arial"/>
         <a:buChar char="»"/>
-        <a:defRPr sz="1200" kern="1200">
+        <a:defRPr sz="1102" kern="1200">
           <a:solidFill>
             <a:schemeClr val="tx1"/>
           </a:solidFill>
@@ -4076,7 +4076,7 @@
         </a:defRPr>
       </a:lvl5pPr>
       <a:lvl6pPr marL="1371600" indent="-228600" algn="l">
-        <a:defRPr sz="1200" kern="1200">
+        <a:defRPr sz="1102" kern="1200">
           <a:solidFill>
             <a:schemeClr val="tx1"/>
           </a:solidFill>
@@ -4084,7 +4084,7 @@
         </a:defRPr>
       </a:lvl6pPr>
       <a:lvl7pPr marL="1600200" indent="-228600" algn="l">
-        <a:defRPr sz="1200" kern="1200">
+        <a:defRPr sz="1102" kern="1200">
           <a:solidFill>
             <a:schemeClr val="tx1"/>
           </a:solidFill>
@@ -4092,7 +4092,7 @@
         </a:defRPr>
       </a:lvl7pPr>
       <a:lvl8pPr marL="1828800" indent="-228600" algn="l">
-        <a:defRPr sz="1200" kern="1200">
+        <a:defRPr sz="1102" kern="1200">
           <a:solidFill>
             <a:schemeClr val="tx1"/>
           </a:solidFill>
@@ -4100,7 +4100,7 @@
         </a:defRPr>
       </a:lvl8pPr>
       <a:lvl9pPr marL="2057400" indent="-228600" algn="l">
-        <a:defRPr sz="1200" kern="1200">
+        <a:defRPr sz="1102" kern="1200">
           <a:solidFill>
             <a:schemeClr val="tx1"/>
           </a:solidFill>
@@ -4113,7 +4113,7 @@
         <a:defRPr lang="en-US"/>
       </a:defPPr>
       <a:lvl1pPr marL="0" algn="l" defTabSz="457200">
-        <a:defRPr sz="1800" kern="1200">
+        <a:defRPr sz="1427" kern="1200">
           <a:solidFill>
             <a:schemeClr val="tx1"/>
           </a:solidFill>
@@ -4123,7 +4123,7 @@
         </a:defRPr>
       </a:lvl1pPr>
       <a:lvl2pPr marL="457200" algn="l" defTabSz="457200">
-        <a:defRPr sz="1800" kern="1200">
+        <a:defRPr sz="1427" kern="1200">
           <a:solidFill>
             <a:schemeClr val="tx1"/>
           </a:solidFill>
@@ -4133,7 +4133,7 @@
         </a:defRPr>
       </a:lvl2pPr>
       <a:lvl3pPr marL="914400" algn="l" defTabSz="457200">
-        <a:defRPr sz="1800" kern="1200">
+        <a:defRPr sz="1427" kern="1200">
           <a:solidFill>
             <a:schemeClr val="tx1"/>
           </a:solidFill>
@@ -4143,7 +4143,7 @@
         </a:defRPr>
       </a:lvl3pPr>
       <a:lvl4pPr marL="1371600" algn="l" defTabSz="457200">
-        <a:defRPr sz="1800" kern="1200">
+        <a:defRPr sz="1427" kern="1200">
           <a:solidFill>
             <a:schemeClr val="tx1"/>
           </a:solidFill>
@@ -4153,7 +4153,7 @@
         </a:defRPr>
       </a:lvl4pPr>
       <a:lvl5pPr marL="1828800" algn="l" defTabSz="457200">
-        <a:defRPr sz="1800" kern="1200">
+        <a:defRPr sz="1427" kern="1200">
           <a:solidFill>
             <a:schemeClr val="tx1"/>
           </a:solidFill>
@@ -4163,7 +4163,7 @@
         </a:defRPr>
       </a:lvl5pPr>
       <a:lvl6pPr marL="2286000" algn="l" defTabSz="457200">
-        <a:defRPr sz="1800" kern="1200">
+        <a:defRPr sz="1427" kern="1200">
           <a:solidFill>
             <a:schemeClr val="tx1"/>
           </a:solidFill>
@@ -4173,7 +4173,7 @@
         </a:defRPr>
       </a:lvl6pPr>
       <a:lvl7pPr marL="2743200" algn="l" defTabSz="457200">
-        <a:defRPr sz="1800" kern="1200">
+        <a:defRPr sz="1427" kern="1200">
           <a:solidFill>
             <a:schemeClr val="tx1"/>
           </a:solidFill>
@@ -4183,7 +4183,7 @@
         </a:defRPr>
       </a:lvl7pPr>
       <a:lvl8pPr marL="3200400" algn="l" defTabSz="457200">
-        <a:defRPr sz="1800" kern="1200">
+        <a:defRPr sz="1427" kern="1200">
           <a:solidFill>
             <a:schemeClr val="tx1"/>
           </a:solidFill>
@@ -4193,7 +4193,7 @@
         </a:defRPr>
       </a:lvl8pPr>
       <a:lvl9pPr marL="3657600" algn="l" defTabSz="457200">
-        <a:defRPr sz="1800" kern="1200">
+        <a:defRPr sz="1427" kern="1200">
           <a:solidFill>
             <a:schemeClr val="tx1"/>
           </a:solidFill>

</xml_diff>

<commit_message>
ncar on the brand template's 10 x 5.625 in (vendor engine #33); docs and README images for type in points
- Vendor engine #33: ncar's pptx is the NSF NCAR template's canvas (9144000 x 5143500,
  screen16x9) at its guidance in points (body 12, levels 12/11/10/9/8, titles 20, cover
  22, bold statement 30); ucar, ucp and ncarucar inherit it, as their templates share it.
- cu: the subtitle at the in-body heads' 20 pt (the NSI cover has none; at 28 a long one
  wrapped and pushed the band title's stack out of the band in HTML).
- Design doc: section 5 "Type" in points, the canvas decision reversed, the log entry
  (incl. the open "Project config" PDF slide). CLAUDE.md: Type and the master ladders.
  README: "Text sizes and the slide size". Screenshots and the livery gallery reshot.

Co-Authored-By: Claude Opus 5.5 <noreply@anthropic.com>
Claude-Session: https://claude.ai/code/session_01QxTZPtUJESWqMyXE15JCRv
</commit_message>
<xml_diff>
--- a/docs/common/_extensions/benkirk/engine/liveries/ncar/template.pptx
+++ b/docs/common/_extensions/benkirk/engine/liveries/ncar/template.pptx
@@ -5,7 +5,7 @@
     <p:sldMasterId id="2147483648" r:id="rId1"/>
   </p:sldMasterIdLst>
   <p:sldIdLst/>
-  <p:sldSz cx="12192000" cy="6858000"/>
+  <p:sldSz cx="9144000" cy="5143500" type="screen16x9"/>
   <p:notesSz cx="6858000" cy="9144000"/>
   <p:defaultTextStyle>
     <a:defPPr>
@@ -49,7 +49,7 @@
         <p:spPr>
           <a:xfrm>
             <a:off x="0" y="0"/>
-            <a:ext cx="12192000" cy="6858000"/>
+            <a:ext cx="9144000" cy="5143500"/>
           </a:xfrm>
           <a:custGeom>
             <a:avLst/>
@@ -108,7 +108,7 @@
         <p:spPr>
           <a:xfrm>
             <a:off x="0" y="0"/>
-            <a:ext cx="12192000" cy="6858000"/>
+            <a:ext cx="9144000" cy="5143500"/>
           </a:xfrm>
           <a:custGeom>
             <a:avLst/>
@@ -167,7 +167,7 @@
         <p:spPr>
           <a:xfrm>
             <a:off x="0" y="0"/>
-            <a:ext cx="12192000" cy="6858000"/>
+            <a:ext cx="9144000" cy="5143500"/>
           </a:xfrm>
           <a:custGeom>
             <a:avLst/>
@@ -194,7 +194,7 @@
             </a:pathLst>
           </a:custGeom>
           <a:noFill/>
-          <a:ln w="18288">
+          <a:ln w="13716">
             <a:solidFill>
               <a:schemeClr val="accent1"/>
             </a:solidFill>
@@ -210,7 +210,7 @@
         <p:spPr>
           <a:xfrm>
             <a:off x="0" y="0"/>
-            <a:ext cx="12192000" cy="6858000"/>
+            <a:ext cx="9144000" cy="5143500"/>
           </a:xfrm>
           <a:custGeom>
             <a:avLst/>
@@ -237,7 +237,7 @@
             </a:pathLst>
           </a:custGeom>
           <a:noFill/>
-          <a:ln w="18288">
+          <a:ln w="13716">
             <a:solidFill>
               <a:schemeClr val="accent1"/>
             </a:solidFill>
@@ -253,7 +253,7 @@
         <p:spPr>
           <a:xfrm>
             <a:off x="0" y="0"/>
-            <a:ext cx="12192000" cy="6858000"/>
+            <a:ext cx="9144000" cy="5143500"/>
           </a:xfrm>
           <a:custGeom>
             <a:avLst/>
@@ -280,7 +280,7 @@
             </a:pathLst>
           </a:custGeom>
           <a:noFill/>
-          <a:ln w="18288">
+          <a:ln w="13716">
             <a:solidFill>
               <a:schemeClr val="accent1"/>
             </a:solidFill>
@@ -303,8 +303,8 @@
         </p:blipFill>
         <p:spPr>
           <a:xfrm>
-            <a:off x="731520" y="411480"/>
-            <a:ext cx="2428646" cy="617220"/>
+            <a:off x="548640" y="308610"/>
+            <a:ext cx="1821485" cy="462915"/>
           </a:xfrm>
           <a:prstGeom prst="rect">
             <a:avLst/>
@@ -319,8 +319,8 @@
         </p:nvSpPr>
         <p:spPr>
           <a:xfrm>
-            <a:off x="0" y="2948940"/>
-            <a:ext cx="219456" cy="1097280"/>
+            <a:off x="0" y="2211705"/>
+            <a:ext cx="164592" cy="822960"/>
           </a:xfrm>
           <a:prstGeom prst="rect">
             <a:avLst/>
@@ -345,8 +345,8 @@
         </p:nvSpPr>
         <p:spPr>
           <a:xfrm>
-            <a:off x="731520" y="2571750"/>
-            <a:ext cx="6096000" cy="308610"/>
+            <a:off x="548640" y="1928812"/>
+            <a:ext cx="4572000" cy="231458"/>
           </a:xfrm>
           <a:prstGeom prst="rect">
             <a:avLst/>
@@ -362,7 +362,7 @@
                 <a:spcPts val="0"/>
               </a:spcBef>
               <a:buNone/>
-              <a:defRPr sz="1100" b="1" cap="all">
+              <a:defRPr sz="800" b="1" cap="all">
                 <a:solidFill>
                   <a:srgbClr val="FFFFFF"/>
                 </a:solidFill>
@@ -390,8 +390,8 @@
         </p:nvSpPr>
         <p:spPr>
           <a:xfrm>
-            <a:off x="731520" y="2948940"/>
-            <a:ext cx="6096000" cy="1097280"/>
+            <a:off x="548640" y="2211705"/>
+            <a:ext cx="4572000" cy="822960"/>
           </a:xfrm>
           <a:prstGeom prst="rect">
             <a:avLst/>
@@ -407,7 +407,7 @@
                 <a:spcPts val="0"/>
               </a:spcBef>
               <a:buNone/>
-              <a:defRPr sz="2900" b="1">
+              <a:defRPr sz="2200" b="1">
                 <a:solidFill>
                   <a:srgbClr val="FFFFFF"/>
                 </a:solidFill>
@@ -431,13 +431,13 @@
         </p:nvCxnSpPr>
         <p:spPr>
           <a:xfrm>
-            <a:off x="731520" y="4217670"/>
-            <a:ext cx="1584960" cy="0"/>
+            <a:off x="548640" y="3163252"/>
+            <a:ext cx="1188720" cy="0"/>
           </a:xfrm>
           <a:prstGeom prst="line">
             <a:avLst/>
           </a:prstGeom>
-          <a:ln w="22631">
+          <a:ln w="16974">
             <a:solidFill>
               <a:schemeClr val="accent1"/>
             </a:solidFill>
@@ -456,8 +456,8 @@
         </p:nvSpPr>
         <p:spPr>
           <a:xfrm>
-            <a:off x="731520" y="4389120"/>
-            <a:ext cx="6096000" cy="1508760"/>
+            <a:off x="548640" y="3291840"/>
+            <a:ext cx="4572000" cy="1131570"/>
           </a:xfrm>
           <a:prstGeom prst="rect">
             <a:avLst/>
@@ -473,7 +473,7 @@
                 <a:spcPts val="0"/>
               </a:spcBef>
               <a:buNone/>
-              <a:defRPr sz="2000" b="0">
+              <a:defRPr sz="1500" b="0">
                 <a:solidFill>
                   <a:srgbClr val="FFFFFF"/>
                 </a:solidFill>
@@ -501,15 +501,15 @@
         </p:nvSpPr>
         <p:spPr>
           <a:xfrm>
-            <a:off x="12192" y="6480810"/>
-            <a:ext cx="475488" cy="363474"/>
+            <a:off x="9144" y="4860608"/>
+            <a:ext cx="356616" cy="272606"/>
           </a:xfrm>
         </p:spPr>
         <p:txBody>
           <a:bodyPr anchor="ctr"/>
           <a:lstStyle>
             <a:lvl1pPr algn="ctr">
-              <a:defRPr sz="900" b="1">
+              <a:defRPr sz="700" b="1">
                 <a:solidFill>
                   <a:srgbClr val="FFFFFF"/>
                 </a:solidFill>
@@ -536,8 +536,8 @@
         </p:nvSpPr>
         <p:spPr>
           <a:xfrm>
-            <a:off x="560832" y="6556248"/>
-            <a:ext cx="4145280" cy="185166"/>
+            <a:off x="420624" y="4917186"/>
+            <a:ext cx="3108960" cy="138874"/>
           </a:xfrm>
           <a:prstGeom prst="rect">
             <a:avLst/>
@@ -547,7 +547,7 @@
           <a:bodyPr vert="horz" lIns="0" tIns="0" rIns="0" bIns="0" anchor="ctr"/>
           <a:lstStyle>
             <a:lvl1pPr algn="l">
-              <a:defRPr sz="900">
+              <a:defRPr sz="700">
                 <a:solidFill>
                   <a:srgbClr val="FFFFFF"/>
                 </a:solidFill>
@@ -604,7 +604,7 @@
         <p:spPr>
           <a:xfrm>
             <a:off x="0" y="0"/>
-            <a:ext cx="12192000" cy="6858000"/>
+            <a:ext cx="9144000" cy="5143500"/>
           </a:xfrm>
           <a:custGeom>
             <a:avLst/>
@@ -631,7 +631,7 @@
             </a:pathLst>
           </a:custGeom>
           <a:noFill/>
-          <a:ln w="18288">
+          <a:ln w="13716">
             <a:solidFill>
               <a:schemeClr val="accent1"/>
             </a:solidFill>
@@ -647,7 +647,7 @@
         <p:spPr>
           <a:xfrm>
             <a:off x="0" y="0"/>
-            <a:ext cx="12192000" cy="6858000"/>
+            <a:ext cx="9144000" cy="5143500"/>
           </a:xfrm>
           <a:custGeom>
             <a:avLst/>
@@ -674,7 +674,7 @@
             </a:pathLst>
           </a:custGeom>
           <a:noFill/>
-          <a:ln w="18288">
+          <a:ln w="13716">
             <a:solidFill>
               <a:schemeClr val="accent1"/>
             </a:solidFill>
@@ -690,7 +690,7 @@
         <p:spPr>
           <a:xfrm>
             <a:off x="0" y="0"/>
-            <a:ext cx="12192000" cy="6858000"/>
+            <a:ext cx="9144000" cy="5143500"/>
           </a:xfrm>
           <a:custGeom>
             <a:avLst/>
@@ -717,7 +717,7 @@
             </a:pathLst>
           </a:custGeom>
           <a:noFill/>
-          <a:ln w="18288">
+          <a:ln w="13716">
             <a:solidFill>
               <a:schemeClr val="accent1"/>
             </a:solidFill>
@@ -740,8 +740,8 @@
         </p:blipFill>
         <p:spPr>
           <a:xfrm>
-            <a:off x="731520" y="617220"/>
-            <a:ext cx="2698090" cy="685800"/>
+            <a:off x="548640" y="462915"/>
+            <a:ext cx="2023567" cy="514350"/>
           </a:xfrm>
           <a:prstGeom prst="rect">
             <a:avLst/>
@@ -756,8 +756,8 @@
         </p:nvSpPr>
         <p:spPr>
           <a:xfrm>
-            <a:off x="0" y="3154680"/>
-            <a:ext cx="219456" cy="514350"/>
+            <a:off x="0" y="2366010"/>
+            <a:ext cx="164592" cy="385762"/>
           </a:xfrm>
           <a:prstGeom prst="rect">
             <a:avLst/>
@@ -782,8 +782,8 @@
         </p:nvSpPr>
         <p:spPr>
           <a:xfrm>
-            <a:off x="731520" y="1508760"/>
-            <a:ext cx="7559040" cy="2263140"/>
+            <a:off x="548640" y="1131570"/>
+            <a:ext cx="5669280" cy="1697355"/>
           </a:xfrm>
           <a:prstGeom prst="rect">
             <a:avLst/>
@@ -798,7 +798,7 @@
               <a:lnSpc>
                 <a:spcPct val="90000"/>
               </a:lnSpc>
-              <a:defRPr sz="4000" b="1">
+              <a:defRPr sz="3000" b="1">
                 <a:solidFill>
                   <a:srgbClr val="00357A"/>
                 </a:solidFill>
@@ -826,8 +826,8 @@
         </p:nvSpPr>
         <p:spPr>
           <a:xfrm>
-            <a:off x="731520" y="3977640"/>
-            <a:ext cx="7559040" cy="2057400"/>
+            <a:off x="548640" y="2983230"/>
+            <a:ext cx="5669280" cy="1543050"/>
           </a:xfrm>
           <a:prstGeom prst="rect">
             <a:avLst/>
@@ -839,21 +839,21 @@
           </a:bodyPr>
           <a:lstStyle>
             <a:lvl1pPr>
-              <a:defRPr sz="1600">
+              <a:defRPr sz="1200">
                 <a:solidFill>
                   <a:srgbClr val="00357A"/>
                 </a:solidFill>
               </a:defRPr>
             </a:lvl1pPr>
             <a:lvl2pPr>
-              <a:defRPr sz="1500">
+              <a:defRPr sz="1100">
                 <a:solidFill>
                   <a:srgbClr val="00357A"/>
                 </a:solidFill>
               </a:defRPr>
             </a:lvl2pPr>
             <a:lvl3pPr>
-              <a:defRPr sz="1300">
+              <a:defRPr sz="1000">
                 <a:solidFill>
                   <a:srgbClr val="00357A"/>
                 </a:solidFill>
@@ -880,15 +880,15 @@
         </p:nvSpPr>
         <p:spPr>
           <a:xfrm>
-            <a:off x="12192" y="6480810"/>
-            <a:ext cx="475488" cy="363474"/>
+            <a:off x="9144" y="4860608"/>
+            <a:ext cx="356616" cy="272606"/>
           </a:xfrm>
         </p:spPr>
         <p:txBody>
           <a:bodyPr anchor="ctr"/>
           <a:lstStyle>
             <a:lvl1pPr algn="ctr">
-              <a:defRPr sz="900" b="1">
+              <a:defRPr sz="700" b="1">
                 <a:solidFill>
                   <a:srgbClr val="00357A"/>
                 </a:solidFill>
@@ -915,8 +915,8 @@
         </p:nvSpPr>
         <p:spPr>
           <a:xfrm>
-            <a:off x="10436352" y="6556248"/>
-            <a:ext cx="1377696" cy="185166"/>
+            <a:off x="7827264" y="4917186"/>
+            <a:ext cx="1033272" cy="138874"/>
           </a:xfrm>
           <a:prstGeom prst="rect">
             <a:avLst/>
@@ -926,7 +926,7 @@
           <a:bodyPr vert="horz" lIns="0" tIns="0" rIns="0" bIns="0" anchor="ctr"/>
           <a:lstStyle>
             <a:lvl1pPr algn="r">
-              <a:defRPr sz="900">
+              <a:defRPr sz="700">
                 <a:solidFill>
                   <a:srgbClr val="00357A"/>
                 </a:solidFill>
@@ -953,8 +953,8 @@
         </p:nvSpPr>
         <p:spPr>
           <a:xfrm>
-            <a:off x="560832" y="6556248"/>
-            <a:ext cx="4145280" cy="185166"/>
+            <a:off x="420624" y="4917186"/>
+            <a:ext cx="3108960" cy="138874"/>
           </a:xfrm>
           <a:prstGeom prst="rect">
             <a:avLst/>
@@ -964,7 +964,7 @@
           <a:bodyPr vert="horz" lIns="0" tIns="0" rIns="0" bIns="0" anchor="ctr"/>
           <a:lstStyle>
             <a:lvl1pPr algn="l">
-              <a:defRPr sz="900">
+              <a:defRPr sz="700">
                 <a:solidFill>
                   <a:srgbClr val="00357A"/>
                 </a:solidFill>
@@ -1042,8 +1042,8 @@
         </p:nvSpPr>
         <p:spPr>
           <a:xfrm>
-            <a:off x="731520" y="1143229"/>
-            <a:ext cx="10728960" cy="5181219"/>
+            <a:off x="548640" y="857421"/>
+            <a:ext cx="8046720" cy="3885914"/>
           </a:xfrm>
           <a:prstGeom prst="rect">
             <a:avLst/>
@@ -1072,15 +1072,15 @@
         </p:nvSpPr>
         <p:spPr>
           <a:xfrm>
-            <a:off x="12192" y="6480810"/>
-            <a:ext cx="475488" cy="363474"/>
+            <a:off x="9144" y="4860608"/>
+            <a:ext cx="356616" cy="272606"/>
           </a:xfrm>
         </p:spPr>
         <p:txBody>
           <a:bodyPr anchor="ctr"/>
           <a:lstStyle>
             <a:lvl1pPr algn="ctr">
-              <a:defRPr sz="900" b="1">
+              <a:defRPr sz="700" b="1">
                 <a:solidFill>
                   <a:schemeClr val="tx1"/>
                 </a:solidFill>
@@ -1107,8 +1107,8 @@
         </p:nvSpPr>
         <p:spPr>
           <a:xfrm>
-            <a:off x="10436352" y="6556248"/>
-            <a:ext cx="1377696" cy="185166"/>
+            <a:off x="7827264" y="4917186"/>
+            <a:ext cx="1033272" cy="138874"/>
           </a:xfrm>
           <a:prstGeom prst="rect">
             <a:avLst/>
@@ -1118,7 +1118,7 @@
           <a:bodyPr vert="horz" lIns="0" tIns="0" rIns="0" bIns="0" anchor="ctr"/>
           <a:lstStyle>
             <a:lvl1pPr algn="r">
-              <a:defRPr sz="900">
+              <a:defRPr sz="700">
                 <a:solidFill>
                   <a:schemeClr val="tx1"/>
                 </a:solidFill>
@@ -1145,8 +1145,8 @@
         </p:nvSpPr>
         <p:spPr>
           <a:xfrm>
-            <a:off x="560832" y="6556248"/>
-            <a:ext cx="4145280" cy="185166"/>
+            <a:off x="420624" y="4917186"/>
+            <a:ext cx="3108960" cy="138874"/>
           </a:xfrm>
           <a:prstGeom prst="rect">
             <a:avLst/>
@@ -1156,7 +1156,7 @@
           <a:bodyPr vert="horz" lIns="0" tIns="0" rIns="0" bIns="0" anchor="ctr"/>
           <a:lstStyle>
             <a:lvl1pPr algn="l">
-              <a:defRPr sz="900">
+              <a:defRPr sz="700">
                 <a:solidFill>
                   <a:schemeClr val="tx1"/>
                 </a:solidFill>
@@ -1213,7 +1213,7 @@
         <p:spPr>
           <a:xfrm>
             <a:off x="0" y="0"/>
-            <a:ext cx="12192000" cy="6858000"/>
+            <a:ext cx="9144000" cy="5143500"/>
           </a:xfrm>
           <a:custGeom>
             <a:avLst/>
@@ -1272,7 +1272,7 @@
         <p:spPr>
           <a:xfrm>
             <a:off x="0" y="0"/>
-            <a:ext cx="12192000" cy="6858000"/>
+            <a:ext cx="9144000" cy="5143500"/>
           </a:xfrm>
           <a:custGeom>
             <a:avLst/>
@@ -1331,7 +1331,7 @@
         <p:spPr>
           <a:xfrm>
             <a:off x="0" y="0"/>
-            <a:ext cx="12192000" cy="6858000"/>
+            <a:ext cx="9144000" cy="5143500"/>
           </a:xfrm>
           <a:custGeom>
             <a:avLst/>
@@ -1358,7 +1358,7 @@
             </a:pathLst>
           </a:custGeom>
           <a:noFill/>
-          <a:ln w="18288">
+          <a:ln w="13716">
             <a:solidFill>
               <a:schemeClr val="accent1"/>
             </a:solidFill>
@@ -1374,7 +1374,7 @@
         <p:spPr>
           <a:xfrm>
             <a:off x="0" y="0"/>
-            <a:ext cx="12192000" cy="6858000"/>
+            <a:ext cx="9144000" cy="5143500"/>
           </a:xfrm>
           <a:custGeom>
             <a:avLst/>
@@ -1401,7 +1401,7 @@
             </a:pathLst>
           </a:custGeom>
           <a:noFill/>
-          <a:ln w="18288">
+          <a:ln w="13716">
             <a:solidFill>
               <a:schemeClr val="accent1"/>
             </a:solidFill>
@@ -1417,7 +1417,7 @@
         <p:spPr>
           <a:xfrm>
             <a:off x="0" y="0"/>
-            <a:ext cx="12192000" cy="6858000"/>
+            <a:ext cx="9144000" cy="5143500"/>
           </a:xfrm>
           <a:custGeom>
             <a:avLst/>
@@ -1444,7 +1444,7 @@
             </a:pathLst>
           </a:custGeom>
           <a:noFill/>
-          <a:ln w="18288">
+          <a:ln w="13716">
             <a:solidFill>
               <a:schemeClr val="accent1"/>
             </a:solidFill>
@@ -1467,8 +1467,8 @@
         </p:blipFill>
         <p:spPr>
           <a:xfrm>
-            <a:off x="731520" y="548640"/>
-            <a:ext cx="2157984" cy="548640"/>
+            <a:off x="548640" y="411480"/>
+            <a:ext cx="1618488" cy="411480"/>
           </a:xfrm>
           <a:prstGeom prst="rect">
             <a:avLst/>
@@ -1487,8 +1487,8 @@
         </p:nvSpPr>
         <p:spPr>
           <a:xfrm>
-            <a:off x="731520" y="2758288"/>
-            <a:ext cx="7559040" cy="822960"/>
+            <a:off x="548640" y="2068716"/>
+            <a:ext cx="5669280" cy="617220"/>
           </a:xfrm>
           <a:prstGeom prst="rect">
             <a:avLst/>
@@ -1503,7 +1503,7 @@
               <a:lnSpc>
                 <a:spcPct val="90000"/>
               </a:lnSpc>
-              <a:defRPr sz="4000" b="1" cap="none" baseline="0">
+              <a:defRPr sz="3000" b="1" cap="none" baseline="0">
                 <a:solidFill>
                   <a:srgbClr val="FFFFFF"/>
                 </a:solidFill>
@@ -1531,8 +1531,8 @@
         </p:nvSpPr>
         <p:spPr>
           <a:xfrm>
-            <a:off x="731520" y="3649828"/>
-            <a:ext cx="7559040" cy="912114"/>
+            <a:off x="548640" y="2737371"/>
+            <a:ext cx="5669280" cy="684086"/>
           </a:xfrm>
           <a:prstGeom prst="rect">
             <a:avLst/>
@@ -1548,7 +1548,7 @@
                 <a:spcPts val="0"/>
               </a:spcBef>
               <a:buNone/>
-              <a:defRPr sz="2000" b="0">
+              <a:defRPr sz="1500" b="0">
                 <a:solidFill>
                   <a:srgbClr val="FFFFFF"/>
                 </a:solidFill>
@@ -1576,15 +1576,15 @@
         </p:nvSpPr>
         <p:spPr>
           <a:xfrm>
-            <a:off x="12192" y="6480810"/>
-            <a:ext cx="475488" cy="363474"/>
+            <a:off x="9144" y="4860608"/>
+            <a:ext cx="356616" cy="272606"/>
           </a:xfrm>
         </p:spPr>
         <p:txBody>
           <a:bodyPr anchor="ctr"/>
           <a:lstStyle>
             <a:lvl1pPr algn="ctr">
-              <a:defRPr sz="900" b="1">
+              <a:defRPr sz="700" b="1">
                 <a:solidFill>
                   <a:srgbClr val="FFFFFF"/>
                 </a:solidFill>
@@ -1611,8 +1611,8 @@
         </p:nvSpPr>
         <p:spPr>
           <a:xfrm>
-            <a:off x="10436352" y="6556248"/>
-            <a:ext cx="1377696" cy="185166"/>
+            <a:off x="7827264" y="4917186"/>
+            <a:ext cx="1033272" cy="138874"/>
           </a:xfrm>
           <a:prstGeom prst="rect">
             <a:avLst/>
@@ -1622,7 +1622,7 @@
           <a:bodyPr vert="horz" lIns="0" tIns="0" rIns="0" bIns="0" anchor="ctr"/>
           <a:lstStyle>
             <a:lvl1pPr algn="r">
-              <a:defRPr sz="900">
+              <a:defRPr sz="700">
                 <a:solidFill>
                   <a:srgbClr val="FFFFFF"/>
                 </a:solidFill>
@@ -1649,8 +1649,8 @@
         </p:nvSpPr>
         <p:spPr>
           <a:xfrm>
-            <a:off x="560832" y="6556248"/>
-            <a:ext cx="4145280" cy="185166"/>
+            <a:off x="420624" y="4917186"/>
+            <a:ext cx="3108960" cy="138874"/>
           </a:xfrm>
           <a:prstGeom prst="rect">
             <a:avLst/>
@@ -1660,7 +1660,7 @@
           <a:bodyPr vert="horz" lIns="0" tIns="0" rIns="0" bIns="0" anchor="ctr"/>
           <a:lstStyle>
             <a:lvl1pPr algn="l">
-              <a:defRPr sz="900">
+              <a:defRPr sz="700">
                 <a:solidFill>
                   <a:srgbClr val="FFFFFF"/>
                 </a:solidFill>
@@ -1738,8 +1738,8 @@
         </p:nvSpPr>
         <p:spPr>
           <a:xfrm>
-            <a:off x="731520" y="1143229"/>
-            <a:ext cx="5181600" cy="5181219"/>
+            <a:off x="548640" y="857421"/>
+            <a:ext cx="3886200" cy="3885914"/>
           </a:xfrm>
           <a:prstGeom prst="rect">
             <a:avLst/>
@@ -1768,8 +1768,8 @@
         </p:nvSpPr>
         <p:spPr>
           <a:xfrm>
-            <a:off x="6278880" y="1143229"/>
-            <a:ext cx="5181600" cy="5181219"/>
+            <a:off x="4709160" y="857421"/>
+            <a:ext cx="3886200" cy="3885914"/>
           </a:xfrm>
           <a:prstGeom prst="rect">
             <a:avLst/>
@@ -1798,15 +1798,15 @@
         </p:nvSpPr>
         <p:spPr>
           <a:xfrm>
-            <a:off x="12192" y="6480810"/>
-            <a:ext cx="475488" cy="363474"/>
+            <a:off x="9144" y="4860608"/>
+            <a:ext cx="356616" cy="272606"/>
           </a:xfrm>
         </p:spPr>
         <p:txBody>
           <a:bodyPr anchor="ctr"/>
           <a:lstStyle>
             <a:lvl1pPr algn="ctr">
-              <a:defRPr sz="900" b="1">
+              <a:defRPr sz="700" b="1">
                 <a:solidFill>
                   <a:schemeClr val="tx1"/>
                 </a:solidFill>
@@ -1833,8 +1833,8 @@
         </p:nvSpPr>
         <p:spPr>
           <a:xfrm>
-            <a:off x="10436352" y="6556248"/>
-            <a:ext cx="1377696" cy="185166"/>
+            <a:off x="7827264" y="4917186"/>
+            <a:ext cx="1033272" cy="138874"/>
           </a:xfrm>
           <a:prstGeom prst="rect">
             <a:avLst/>
@@ -1844,7 +1844,7 @@
           <a:bodyPr vert="horz" lIns="0" tIns="0" rIns="0" bIns="0" anchor="ctr"/>
           <a:lstStyle>
             <a:lvl1pPr algn="r">
-              <a:defRPr sz="900">
+              <a:defRPr sz="700">
                 <a:solidFill>
                   <a:schemeClr val="tx1"/>
                 </a:solidFill>
@@ -1871,8 +1871,8 @@
         </p:nvSpPr>
         <p:spPr>
           <a:xfrm>
-            <a:off x="560832" y="6556248"/>
-            <a:ext cx="4145280" cy="185166"/>
+            <a:off x="420624" y="4917186"/>
+            <a:ext cx="3108960" cy="138874"/>
           </a:xfrm>
           <a:prstGeom prst="rect">
             <a:avLst/>
@@ -1882,7 +1882,7 @@
           <a:bodyPr vert="horz" lIns="0" tIns="0" rIns="0" bIns="0" anchor="ctr"/>
           <a:lstStyle>
             <a:lvl1pPr algn="l">
-              <a:defRPr sz="900">
+              <a:defRPr sz="700">
                 <a:solidFill>
                   <a:schemeClr val="tx1"/>
                 </a:solidFill>
@@ -1960,8 +1960,8 @@
         </p:nvSpPr>
         <p:spPr>
           <a:xfrm>
-            <a:off x="731520" y="1143229"/>
-            <a:ext cx="5181600" cy="617220"/>
+            <a:off x="548640" y="857421"/>
+            <a:ext cx="3886200" cy="462915"/>
           </a:xfrm>
           <a:prstGeom prst="rect">
             <a:avLst/>
@@ -1974,7 +1974,7 @@
           <a:lstStyle>
             <a:lvl1pPr marL="0" indent="0">
               <a:buNone/>
-              <a:defRPr sz="2000" b="1">
+              <a:defRPr sz="1500" b="1">
                 <a:solidFill>
                   <a:schemeClr val="tx2"/>
                 </a:solidFill>
@@ -2001,8 +2001,8 @@
         </p:nvSpPr>
         <p:spPr>
           <a:xfrm>
-            <a:off x="731520" y="1829029"/>
-            <a:ext cx="5181600" cy="4495419"/>
+            <a:off x="548640" y="1371771"/>
+            <a:ext cx="3886200" cy="3371564"/>
           </a:xfrm>
           <a:prstGeom prst="rect">
             <a:avLst/>
@@ -2031,8 +2031,8 @@
         </p:nvSpPr>
         <p:spPr>
           <a:xfrm>
-            <a:off x="6278880" y="1143229"/>
-            <a:ext cx="5181600" cy="617220"/>
+            <a:off x="4709160" y="857421"/>
+            <a:ext cx="3886200" cy="462915"/>
           </a:xfrm>
           <a:prstGeom prst="rect">
             <a:avLst/>
@@ -2045,7 +2045,7 @@
           <a:lstStyle>
             <a:lvl1pPr marL="0" indent="0">
               <a:buNone/>
-              <a:defRPr sz="2000" b="1">
+              <a:defRPr sz="1500" b="1">
                 <a:solidFill>
                   <a:schemeClr val="tx2"/>
                 </a:solidFill>
@@ -2072,8 +2072,8 @@
         </p:nvSpPr>
         <p:spPr>
           <a:xfrm>
-            <a:off x="6278880" y="1829029"/>
-            <a:ext cx="5181600" cy="4495419"/>
+            <a:off x="4709160" y="1371771"/>
+            <a:ext cx="3886200" cy="3371564"/>
           </a:xfrm>
           <a:prstGeom prst="rect">
             <a:avLst/>
@@ -2102,15 +2102,15 @@
         </p:nvSpPr>
         <p:spPr>
           <a:xfrm>
-            <a:off x="12192" y="6480810"/>
-            <a:ext cx="475488" cy="363474"/>
+            <a:off x="9144" y="4860608"/>
+            <a:ext cx="356616" cy="272606"/>
           </a:xfrm>
         </p:spPr>
         <p:txBody>
           <a:bodyPr anchor="ctr"/>
           <a:lstStyle>
             <a:lvl1pPr algn="ctr">
-              <a:defRPr sz="900" b="1">
+              <a:defRPr sz="700" b="1">
                 <a:solidFill>
                   <a:schemeClr val="tx1"/>
                 </a:solidFill>
@@ -2137,8 +2137,8 @@
         </p:nvSpPr>
         <p:spPr>
           <a:xfrm>
-            <a:off x="10436352" y="6556248"/>
-            <a:ext cx="1377696" cy="185166"/>
+            <a:off x="7827264" y="4917186"/>
+            <a:ext cx="1033272" cy="138874"/>
           </a:xfrm>
           <a:prstGeom prst="rect">
             <a:avLst/>
@@ -2148,7 +2148,7 @@
           <a:bodyPr vert="horz" lIns="0" tIns="0" rIns="0" bIns="0" anchor="ctr"/>
           <a:lstStyle>
             <a:lvl1pPr algn="r">
-              <a:defRPr sz="900">
+              <a:defRPr sz="700">
                 <a:solidFill>
                   <a:schemeClr val="tx1"/>
                 </a:solidFill>
@@ -2175,8 +2175,8 @@
         </p:nvSpPr>
         <p:spPr>
           <a:xfrm>
-            <a:off x="560832" y="6556248"/>
-            <a:ext cx="4145280" cy="185166"/>
+            <a:off x="420624" y="4917186"/>
+            <a:ext cx="3108960" cy="138874"/>
           </a:xfrm>
           <a:prstGeom prst="rect">
             <a:avLst/>
@@ -2186,7 +2186,7 @@
           <a:bodyPr vert="horz" lIns="0" tIns="0" rIns="0" bIns="0" anchor="ctr"/>
           <a:lstStyle>
             <a:lvl1pPr algn="l">
-              <a:defRPr sz="900">
+              <a:defRPr sz="700">
                 <a:solidFill>
                   <a:schemeClr val="tx1"/>
                 </a:solidFill>
@@ -2238,8 +2238,8 @@
         </p:nvSpPr>
         <p:spPr>
           <a:xfrm>
-            <a:off x="731520" y="1143229"/>
-            <a:ext cx="4023360" cy="891540"/>
+            <a:off x="548640" y="857421"/>
+            <a:ext cx="3017520" cy="668655"/>
           </a:xfrm>
           <a:prstGeom prst="rect">
             <a:avLst/>
@@ -2251,7 +2251,7 @@
           </a:bodyPr>
           <a:lstStyle>
             <a:lvl1pPr algn="l">
-              <a:defRPr sz="2000" b="1"/>
+              <a:defRPr sz="1500" b="1"/>
             </a:lvl1pPr>
           </a:lstStyle>
           <a:p>
@@ -2274,8 +2274,8 @@
         </p:nvSpPr>
         <p:spPr>
           <a:xfrm>
-            <a:off x="5120640" y="1143229"/>
-            <a:ext cx="6339840" cy="5181219"/>
+            <a:off x="3840480" y="857421"/>
+            <a:ext cx="4754880" cy="3885914"/>
           </a:xfrm>
           <a:prstGeom prst="rect">
             <a:avLst/>
@@ -2304,8 +2304,8 @@
         </p:nvSpPr>
         <p:spPr>
           <a:xfrm>
-            <a:off x="731520" y="2103349"/>
-            <a:ext cx="4023360" cy="4221099"/>
+            <a:off x="548640" y="1577511"/>
+            <a:ext cx="3017520" cy="3165824"/>
           </a:xfrm>
           <a:prstGeom prst="rect">
             <a:avLst/>
@@ -2318,7 +2318,7 @@
           <a:lstStyle>
             <a:lvl1pPr marL="0" indent="0">
               <a:buNone/>
-              <a:defRPr sz="1300"/>
+              <a:defRPr sz="1000"/>
             </a:lvl1pPr>
           </a:lstStyle>
           <a:p>
@@ -2341,15 +2341,15 @@
         </p:nvSpPr>
         <p:spPr>
           <a:xfrm>
-            <a:off x="12192" y="6480810"/>
-            <a:ext cx="475488" cy="363474"/>
+            <a:off x="9144" y="4860608"/>
+            <a:ext cx="356616" cy="272606"/>
           </a:xfrm>
         </p:spPr>
         <p:txBody>
           <a:bodyPr anchor="ctr"/>
           <a:lstStyle>
             <a:lvl1pPr algn="ctr">
-              <a:defRPr sz="900" b="1">
+              <a:defRPr sz="700" b="1">
                 <a:solidFill>
                   <a:schemeClr val="tx1"/>
                 </a:solidFill>
@@ -2376,8 +2376,8 @@
         </p:nvSpPr>
         <p:spPr>
           <a:xfrm>
-            <a:off x="10436352" y="6556248"/>
-            <a:ext cx="1377696" cy="185166"/>
+            <a:off x="7827264" y="4917186"/>
+            <a:ext cx="1033272" cy="138874"/>
           </a:xfrm>
           <a:prstGeom prst="rect">
             <a:avLst/>
@@ -2387,7 +2387,7 @@
           <a:bodyPr vert="horz" lIns="0" tIns="0" rIns="0" bIns="0" anchor="ctr"/>
           <a:lstStyle>
             <a:lvl1pPr algn="r">
-              <a:defRPr sz="900">
+              <a:defRPr sz="700">
                 <a:solidFill>
                   <a:schemeClr val="tx1"/>
                 </a:solidFill>
@@ -2414,8 +2414,8 @@
         </p:nvSpPr>
         <p:spPr>
           <a:xfrm>
-            <a:off x="560832" y="6556248"/>
-            <a:ext cx="4145280" cy="185166"/>
+            <a:off x="420624" y="4917186"/>
+            <a:ext cx="3108960" cy="138874"/>
           </a:xfrm>
           <a:prstGeom prst="rect">
             <a:avLst/>
@@ -2425,7 +2425,7 @@
           <a:bodyPr vert="horz" lIns="0" tIns="0" rIns="0" bIns="0" anchor="ctr"/>
           <a:lstStyle>
             <a:lvl1pPr algn="l">
-              <a:defRPr sz="900">
+              <a:defRPr sz="700">
                 <a:solidFill>
                   <a:schemeClr val="tx1"/>
                 </a:solidFill>
@@ -2477,15 +2477,15 @@
         </p:nvSpPr>
         <p:spPr>
           <a:xfrm>
-            <a:off x="12192" y="6480810"/>
-            <a:ext cx="475488" cy="363474"/>
+            <a:off x="9144" y="4860608"/>
+            <a:ext cx="356616" cy="272606"/>
           </a:xfrm>
         </p:spPr>
         <p:txBody>
           <a:bodyPr anchor="ctr"/>
           <a:lstStyle>
             <a:lvl1pPr algn="ctr">
-              <a:defRPr sz="900" b="1">
+              <a:defRPr sz="700" b="1">
                 <a:solidFill>
                   <a:schemeClr val="tx1"/>
                 </a:solidFill>
@@ -2512,8 +2512,8 @@
         </p:nvSpPr>
         <p:spPr>
           <a:xfrm>
-            <a:off x="10436352" y="6556248"/>
-            <a:ext cx="1377696" cy="185166"/>
+            <a:off x="7827264" y="4917186"/>
+            <a:ext cx="1033272" cy="138874"/>
           </a:xfrm>
           <a:prstGeom prst="rect">
             <a:avLst/>
@@ -2523,7 +2523,7 @@
           <a:bodyPr vert="horz" lIns="0" tIns="0" rIns="0" bIns="0" anchor="ctr"/>
           <a:lstStyle>
             <a:lvl1pPr algn="r">
-              <a:defRPr sz="900">
+              <a:defRPr sz="700">
                 <a:solidFill>
                   <a:schemeClr val="tx1"/>
                 </a:solidFill>
@@ -2550,8 +2550,8 @@
         </p:nvSpPr>
         <p:spPr>
           <a:xfrm>
-            <a:off x="560832" y="6556248"/>
-            <a:ext cx="4145280" cy="185166"/>
+            <a:off x="420624" y="4917186"/>
+            <a:ext cx="3108960" cy="138874"/>
           </a:xfrm>
           <a:prstGeom prst="rect">
             <a:avLst/>
@@ -2561,7 +2561,7 @@
           <a:bodyPr vert="horz" lIns="0" tIns="0" rIns="0" bIns="0" anchor="ctr"/>
           <a:lstStyle>
             <a:lvl1pPr algn="l">
-              <a:defRPr sz="900">
+              <a:defRPr sz="700">
                 <a:solidFill>
                   <a:schemeClr val="tx1"/>
                 </a:solidFill>
@@ -2618,7 +2618,7 @@
         <p:spPr>
           <a:xfrm>
             <a:off x="0" y="0"/>
-            <a:ext cx="12192000" cy="6858000"/>
+            <a:ext cx="9144000" cy="5143500"/>
           </a:xfrm>
           <a:custGeom>
             <a:avLst/>
@@ -2677,7 +2677,7 @@
         <p:spPr>
           <a:xfrm>
             <a:off x="0" y="0"/>
-            <a:ext cx="12192000" cy="6858000"/>
+            <a:ext cx="9144000" cy="5143500"/>
           </a:xfrm>
           <a:custGeom>
             <a:avLst/>
@@ -2736,7 +2736,7 @@
         <p:spPr>
           <a:xfrm>
             <a:off x="0" y="0"/>
-            <a:ext cx="12192000" cy="6858000"/>
+            <a:ext cx="9144000" cy="5143500"/>
           </a:xfrm>
           <a:custGeom>
             <a:avLst/>
@@ -2763,7 +2763,7 @@
             </a:pathLst>
           </a:custGeom>
           <a:noFill/>
-          <a:ln w="18288">
+          <a:ln w="13716">
             <a:solidFill>
               <a:schemeClr val="accent1"/>
             </a:solidFill>
@@ -2779,7 +2779,7 @@
         <p:spPr>
           <a:xfrm>
             <a:off x="0" y="0"/>
-            <a:ext cx="12192000" cy="6858000"/>
+            <a:ext cx="9144000" cy="5143500"/>
           </a:xfrm>
           <a:custGeom>
             <a:avLst/>
@@ -2806,7 +2806,7 @@
             </a:pathLst>
           </a:custGeom>
           <a:noFill/>
-          <a:ln w="18288">
+          <a:ln w="13716">
             <a:solidFill>
               <a:schemeClr val="accent1"/>
             </a:solidFill>
@@ -2822,7 +2822,7 @@
         <p:spPr>
           <a:xfrm>
             <a:off x="0" y="0"/>
-            <a:ext cx="12192000" cy="6858000"/>
+            <a:ext cx="9144000" cy="5143500"/>
           </a:xfrm>
           <a:custGeom>
             <a:avLst/>
@@ -2849,7 +2849,7 @@
             </a:pathLst>
           </a:custGeom>
           <a:noFill/>
-          <a:ln w="18288">
+          <a:ln w="13716">
             <a:solidFill>
               <a:schemeClr val="accent1"/>
             </a:solidFill>
@@ -2872,8 +2872,8 @@
         </p:blipFill>
         <p:spPr>
           <a:xfrm>
-            <a:off x="731520" y="617220"/>
-            <a:ext cx="2698090" cy="685800"/>
+            <a:off x="548640" y="462915"/>
+            <a:ext cx="2023567" cy="514350"/>
           </a:xfrm>
           <a:prstGeom prst="rect">
             <a:avLst/>
@@ -2888,8 +2888,8 @@
         </p:nvSpPr>
         <p:spPr>
           <a:xfrm>
-            <a:off x="0" y="3154680"/>
-            <a:ext cx="219456" cy="514350"/>
+            <a:off x="0" y="2366010"/>
+            <a:ext cx="164592" cy="385762"/>
           </a:xfrm>
           <a:prstGeom prst="rect">
             <a:avLst/>
@@ -2914,8 +2914,8 @@
         </p:nvSpPr>
         <p:spPr>
           <a:xfrm>
-            <a:off x="731520" y="1508760"/>
-            <a:ext cx="7559040" cy="2263140"/>
+            <a:off x="548640" y="1131570"/>
+            <a:ext cx="5669280" cy="1697355"/>
           </a:xfrm>
           <a:prstGeom prst="rect">
             <a:avLst/>
@@ -2930,7 +2930,7 @@
               <a:lnSpc>
                 <a:spcPct val="90000"/>
               </a:lnSpc>
-              <a:defRPr sz="4000" b="1">
+              <a:defRPr sz="3000" b="1">
                 <a:solidFill>
                   <a:srgbClr val="FFFFFF"/>
                 </a:solidFill>
@@ -2958,8 +2958,8 @@
         </p:nvSpPr>
         <p:spPr>
           <a:xfrm>
-            <a:off x="731520" y="3977640"/>
-            <a:ext cx="7559040" cy="2057400"/>
+            <a:off x="548640" y="2983230"/>
+            <a:ext cx="5669280" cy="1543050"/>
           </a:xfrm>
           <a:prstGeom prst="rect">
             <a:avLst/>
@@ -2971,21 +2971,21 @@
           </a:bodyPr>
           <a:lstStyle>
             <a:lvl1pPr>
-              <a:defRPr sz="1600">
+              <a:defRPr sz="1200">
                 <a:solidFill>
                   <a:srgbClr val="FFFFFF"/>
                 </a:solidFill>
               </a:defRPr>
             </a:lvl1pPr>
             <a:lvl2pPr>
-              <a:defRPr sz="1500">
+              <a:defRPr sz="1100">
                 <a:solidFill>
                   <a:srgbClr val="FFFFFF"/>
                 </a:solidFill>
               </a:defRPr>
             </a:lvl2pPr>
             <a:lvl3pPr>
-              <a:defRPr sz="1300">
+              <a:defRPr sz="1000">
                 <a:solidFill>
                   <a:srgbClr val="FFFFFF"/>
                 </a:solidFill>
@@ -3012,15 +3012,15 @@
         </p:nvSpPr>
         <p:spPr>
           <a:xfrm>
-            <a:off x="12192" y="6480810"/>
-            <a:ext cx="475488" cy="363474"/>
+            <a:off x="9144" y="4860608"/>
+            <a:ext cx="356616" cy="272606"/>
           </a:xfrm>
         </p:spPr>
         <p:txBody>
           <a:bodyPr anchor="ctr"/>
           <a:lstStyle>
             <a:lvl1pPr algn="ctr">
-              <a:defRPr sz="900" b="1">
+              <a:defRPr sz="700" b="1">
                 <a:solidFill>
                   <a:srgbClr val="FFFFFF"/>
                 </a:solidFill>
@@ -3047,8 +3047,8 @@
         </p:nvSpPr>
         <p:spPr>
           <a:xfrm>
-            <a:off x="10436352" y="6556248"/>
-            <a:ext cx="1377696" cy="185166"/>
+            <a:off x="7827264" y="4917186"/>
+            <a:ext cx="1033272" cy="138874"/>
           </a:xfrm>
           <a:prstGeom prst="rect">
             <a:avLst/>
@@ -3058,7 +3058,7 @@
           <a:bodyPr vert="horz" lIns="0" tIns="0" rIns="0" bIns="0" anchor="ctr"/>
           <a:lstStyle>
             <a:lvl1pPr algn="r">
-              <a:defRPr sz="900">
+              <a:defRPr sz="700">
                 <a:solidFill>
                   <a:srgbClr val="FFFFFF"/>
                 </a:solidFill>
@@ -3085,8 +3085,8 @@
         </p:nvSpPr>
         <p:spPr>
           <a:xfrm>
-            <a:off x="560832" y="6556248"/>
-            <a:ext cx="4145280" cy="185166"/>
+            <a:off x="420624" y="4917186"/>
+            <a:ext cx="3108960" cy="138874"/>
           </a:xfrm>
           <a:prstGeom prst="rect">
             <a:avLst/>
@@ -3096,7 +3096,7 @@
           <a:bodyPr vert="horz" lIns="0" tIns="0" rIns="0" bIns="0" anchor="ctr"/>
           <a:lstStyle>
             <a:lvl1pPr algn="l">
-              <a:defRPr sz="900">
+              <a:defRPr sz="700">
                 <a:solidFill>
                   <a:srgbClr val="FFFFFF"/>
                 </a:solidFill>
@@ -3153,7 +3153,7 @@
         <p:spPr>
           <a:xfrm>
             <a:off x="0" y="0"/>
-            <a:ext cx="12192000" cy="6858000"/>
+            <a:ext cx="9144000" cy="5143500"/>
           </a:xfrm>
           <a:custGeom>
             <a:avLst/>
@@ -3180,7 +3180,7 @@
             </a:pathLst>
           </a:custGeom>
           <a:noFill/>
-          <a:ln w="18288">
+          <a:ln w="13716">
             <a:solidFill>
               <a:schemeClr val="accent1"/>
             </a:solidFill>
@@ -3196,7 +3196,7 @@
         <p:spPr>
           <a:xfrm>
             <a:off x="0" y="0"/>
-            <a:ext cx="12192000" cy="6858000"/>
+            <a:ext cx="9144000" cy="5143500"/>
           </a:xfrm>
           <a:custGeom>
             <a:avLst/>
@@ -3223,7 +3223,7 @@
             </a:pathLst>
           </a:custGeom>
           <a:noFill/>
-          <a:ln w="18288">
+          <a:ln w="13716">
             <a:solidFill>
               <a:schemeClr val="accent1"/>
             </a:solidFill>
@@ -3239,7 +3239,7 @@
         <p:spPr>
           <a:xfrm>
             <a:off x="0" y="0"/>
-            <a:ext cx="12192000" cy="6858000"/>
+            <a:ext cx="9144000" cy="5143500"/>
           </a:xfrm>
           <a:custGeom>
             <a:avLst/>
@@ -3266,7 +3266,7 @@
             </a:pathLst>
           </a:custGeom>
           <a:noFill/>
-          <a:ln w="18288">
+          <a:ln w="13716">
             <a:solidFill>
               <a:schemeClr val="accent1"/>
             </a:solidFill>
@@ -3289,8 +3289,8 @@
         </p:blipFill>
         <p:spPr>
           <a:xfrm>
-            <a:off x="731520" y="411480"/>
-            <a:ext cx="2428646" cy="617220"/>
+            <a:off x="548640" y="308610"/>
+            <a:ext cx="1821485" cy="462915"/>
           </a:xfrm>
           <a:prstGeom prst="rect">
             <a:avLst/>
@@ -3305,8 +3305,8 @@
         </p:nvSpPr>
         <p:spPr>
           <a:xfrm>
-            <a:off x="0" y="2948940"/>
-            <a:ext cx="219456" cy="1097280"/>
+            <a:off x="0" y="2211705"/>
+            <a:ext cx="164592" cy="822960"/>
           </a:xfrm>
           <a:prstGeom prst="rect">
             <a:avLst/>
@@ -3331,8 +3331,8 @@
         </p:nvSpPr>
         <p:spPr>
           <a:xfrm>
-            <a:off x="731520" y="2571750"/>
-            <a:ext cx="6096000" cy="308610"/>
+            <a:off x="548640" y="1928812"/>
+            <a:ext cx="4572000" cy="231458"/>
           </a:xfrm>
           <a:prstGeom prst="rect">
             <a:avLst/>
@@ -3348,7 +3348,7 @@
                 <a:spcPts val="0"/>
               </a:spcBef>
               <a:buNone/>
-              <a:defRPr sz="1100" b="1" cap="all">
+              <a:defRPr sz="800" b="1" cap="all">
                 <a:solidFill>
                   <a:srgbClr val="00357A"/>
                 </a:solidFill>
@@ -3376,8 +3376,8 @@
         </p:nvSpPr>
         <p:spPr>
           <a:xfrm>
-            <a:off x="731520" y="2948940"/>
-            <a:ext cx="6096000" cy="1097280"/>
+            <a:off x="548640" y="2211705"/>
+            <a:ext cx="4572000" cy="822960"/>
           </a:xfrm>
           <a:prstGeom prst="rect">
             <a:avLst/>
@@ -3393,7 +3393,7 @@
                 <a:spcPts val="0"/>
               </a:spcBef>
               <a:buNone/>
-              <a:defRPr sz="2900" b="1">
+              <a:defRPr sz="2200" b="1">
                 <a:solidFill>
                   <a:srgbClr val="00357A"/>
                 </a:solidFill>
@@ -3417,13 +3417,13 @@
         </p:nvCxnSpPr>
         <p:spPr>
           <a:xfrm>
-            <a:off x="731520" y="4217670"/>
-            <a:ext cx="1584960" cy="0"/>
+            <a:off x="548640" y="3163252"/>
+            <a:ext cx="1188720" cy="0"/>
           </a:xfrm>
           <a:prstGeom prst="line">
             <a:avLst/>
           </a:prstGeom>
-          <a:ln w="22631">
+          <a:ln w="16974">
             <a:solidFill>
               <a:schemeClr val="accent1"/>
             </a:solidFill>
@@ -3442,8 +3442,8 @@
         </p:nvSpPr>
         <p:spPr>
           <a:xfrm>
-            <a:off x="731520" y="4389120"/>
-            <a:ext cx="6096000" cy="1508760"/>
+            <a:off x="548640" y="3291840"/>
+            <a:ext cx="4572000" cy="1131570"/>
           </a:xfrm>
           <a:prstGeom prst="rect">
             <a:avLst/>
@@ -3459,7 +3459,7 @@
                 <a:spcPts val="0"/>
               </a:spcBef>
               <a:buNone/>
-              <a:defRPr sz="2000" b="0">
+              <a:defRPr sz="1500" b="0">
                 <a:solidFill>
                   <a:srgbClr val="00357A"/>
                 </a:solidFill>
@@ -3487,15 +3487,15 @@
         </p:nvSpPr>
         <p:spPr>
           <a:xfrm>
-            <a:off x="12192" y="6480810"/>
-            <a:ext cx="475488" cy="363474"/>
+            <a:off x="9144" y="4860608"/>
+            <a:ext cx="356616" cy="272606"/>
           </a:xfrm>
         </p:spPr>
         <p:txBody>
           <a:bodyPr anchor="ctr"/>
           <a:lstStyle>
             <a:lvl1pPr algn="ctr">
-              <a:defRPr sz="900" b="1">
+              <a:defRPr sz="700" b="1">
                 <a:solidFill>
                   <a:srgbClr val="00357A"/>
                 </a:solidFill>
@@ -3522,8 +3522,8 @@
         </p:nvSpPr>
         <p:spPr>
           <a:xfrm>
-            <a:off x="560832" y="6556248"/>
-            <a:ext cx="4145280" cy="185166"/>
+            <a:off x="420624" y="4917186"/>
+            <a:ext cx="3108960" cy="138874"/>
           </a:xfrm>
           <a:prstGeom prst="rect">
             <a:avLst/>
@@ -3533,7 +3533,7 @@
           <a:bodyPr vert="horz" lIns="0" tIns="0" rIns="0" bIns="0" anchor="ctr"/>
           <a:lstStyle>
             <a:lvl1pPr algn="l">
-              <a:defRPr sz="900">
+              <a:defRPr sz="700">
                 <a:solidFill>
                   <a:srgbClr val="00357A"/>
                 </a:solidFill>
@@ -3587,7 +3587,7 @@
         <p:spPr>
           <a:xfrm>
             <a:off x="0" y="0"/>
-            <a:ext cx="12192000" cy="6858000"/>
+            <a:ext cx="9144000" cy="5143500"/>
           </a:xfrm>
           <a:custGeom>
             <a:avLst/>
@@ -3614,7 +3614,7 @@
             </a:pathLst>
           </a:custGeom>
           <a:noFill/>
-          <a:ln w="18288">
+          <a:ln w="13716">
             <a:solidFill>
               <a:schemeClr val="lt2"/>
             </a:solidFill>
@@ -3630,7 +3630,7 @@
         <p:spPr>
           <a:xfrm>
             <a:off x="0" y="0"/>
-            <a:ext cx="12192000" cy="6858000"/>
+            <a:ext cx="9144000" cy="5143500"/>
           </a:xfrm>
           <a:custGeom>
             <a:avLst/>
@@ -3657,7 +3657,7 @@
             </a:pathLst>
           </a:custGeom>
           <a:noFill/>
-          <a:ln w="18288">
+          <a:ln w="13716">
             <a:solidFill>
               <a:schemeClr val="lt2"/>
             </a:solidFill>
@@ -3673,7 +3673,7 @@
         <p:spPr>
           <a:xfrm>
             <a:off x="0" y="0"/>
-            <a:ext cx="12192000" cy="6858000"/>
+            <a:ext cx="9144000" cy="5143500"/>
           </a:xfrm>
           <a:custGeom>
             <a:avLst/>
@@ -3700,7 +3700,7 @@
             </a:pathLst>
           </a:custGeom>
           <a:noFill/>
-          <a:ln w="18288">
+          <a:ln w="13716">
             <a:solidFill>
               <a:schemeClr val="lt2"/>
             </a:solidFill>
@@ -3715,8 +3715,8 @@
         </p:nvSpPr>
         <p:spPr>
           <a:xfrm>
-            <a:off x="0" y="336042"/>
-            <a:ext cx="219456" cy="654253"/>
+            <a:off x="0" y="252032"/>
+            <a:ext cx="164592" cy="490690"/>
           </a:xfrm>
           <a:prstGeom prst="rect">
             <a:avLst/>
@@ -3737,8 +3737,8 @@
         </p:nvCxnSpPr>
         <p:spPr>
           <a:xfrm>
-            <a:off x="731520" y="990295"/>
-            <a:ext cx="10728960" cy="0"/>
+            <a:off x="548640" y="742721"/>
+            <a:ext cx="8046720" cy="0"/>
           </a:xfrm>
           <a:prstGeom prst="line">
             <a:avLst/>
@@ -3764,8 +3764,8 @@
         </p:nvSpPr>
         <p:spPr>
           <a:xfrm>
-            <a:off x="731520" y="336042"/>
-            <a:ext cx="8686688" cy="654253"/>
+            <a:off x="548640" y="252032"/>
+            <a:ext cx="6515016" cy="490690"/>
           </a:xfrm>
           <a:prstGeom prst="rect">
             <a:avLst/>
@@ -3796,15 +3796,15 @@
         </p:nvSpPr>
         <p:spPr>
           <a:xfrm>
-            <a:off x="731520" y="1143229"/>
-            <a:ext cx="10728960" cy="5181219"/>
-          </a:xfrm>
-          <a:prstGeom prst="rect">
-            <a:avLst/>
-          </a:prstGeom>
-        </p:spPr>
-        <p:txBody>
-          <a:bodyPr vert="horz" lIns="0" tIns="45720" rIns="0" bIns="45720">
+            <a:off x="548640" y="857421"/>
+            <a:ext cx="8046720" cy="3885914"/>
+          </a:xfrm>
+          <a:prstGeom prst="rect">
+            <a:avLst/>
+          </a:prstGeom>
+        </p:spPr>
+        <p:txBody>
+          <a:bodyPr vert="horz" lIns="0" tIns="34290" rIns="0" bIns="34290">
             <a:normAutofit/>
           </a:bodyPr>
           <a:lstStyle/>
@@ -3829,15 +3829,15 @@
         </p:nvSpPr>
         <p:spPr>
           <a:xfrm>
-            <a:off x="12192" y="6480810"/>
-            <a:ext cx="475488" cy="363474"/>
+            <a:off x="9144" y="4860608"/>
+            <a:ext cx="356616" cy="272606"/>
           </a:xfrm>
         </p:spPr>
         <p:txBody>
           <a:bodyPr anchor="ctr"/>
           <a:lstStyle>
             <a:lvl1pPr algn="ctr">
-              <a:defRPr sz="900" b="1">
+              <a:defRPr sz="700" b="1">
                 <a:solidFill>
                   <a:schemeClr val="tx1"/>
                 </a:solidFill>
@@ -3864,8 +3864,8 @@
         </p:nvSpPr>
         <p:spPr>
           <a:xfrm>
-            <a:off x="10436352" y="6556248"/>
-            <a:ext cx="1377696" cy="185166"/>
+            <a:off x="7827264" y="4917186"/>
+            <a:ext cx="1033272" cy="138874"/>
           </a:xfrm>
           <a:prstGeom prst="rect">
             <a:avLst/>
@@ -3875,7 +3875,7 @@
           <a:bodyPr vert="horz" lIns="0" tIns="0" rIns="0" bIns="0" anchor="ctr"/>
           <a:lstStyle>
             <a:lvl1pPr algn="r">
-              <a:defRPr sz="900">
+              <a:defRPr sz="700">
                 <a:solidFill>
                   <a:schemeClr val="tx1"/>
                 </a:solidFill>
@@ -3902,8 +3902,8 @@
         </p:nvSpPr>
         <p:spPr>
           <a:xfrm>
-            <a:off x="560832" y="6556248"/>
-            <a:ext cx="4145280" cy="185166"/>
+            <a:off x="420624" y="4917186"/>
+            <a:ext cx="3108960" cy="138874"/>
           </a:xfrm>
           <a:prstGeom prst="rect">
             <a:avLst/>
@@ -3913,7 +3913,7 @@
           <a:bodyPr vert="horz" lIns="0" tIns="0" rIns="0" bIns="0" anchor="ctr"/>
           <a:lstStyle>
             <a:lvl1pPr algn="l">
-              <a:defRPr sz="900">
+              <a:defRPr sz="700">
                 <a:solidFill>
                   <a:schemeClr val="tx1"/>
                 </a:solidFill>
@@ -3944,8 +3944,8 @@
         </p:blipFill>
         <p:spPr>
           <a:xfrm>
-            <a:off x="9723008" y="365531"/>
-            <a:ext cx="1737472" cy="441655"/>
+            <a:off x="7292256" y="274149"/>
+            <a:ext cx="1303104" cy="331241"/>
           </a:xfrm>
           <a:prstGeom prst="rect">
             <a:avLst/>
@@ -3969,12 +3969,12 @@
   </p:sldLayoutIdLst>
   <p:txStyles>
     <p:titleStyle>
-      <a:lvl1pPr algn="l" defTabSz="457200" rtl="0" eaLnBrk="1" latinLnBrk="0" hangingPunct="1">
+      <a:lvl1pPr algn="l" defTabSz="342900" rtl="0" eaLnBrk="1" latinLnBrk="0" hangingPunct="1">
         <a:spcBef>
           <a:spcPct val="0"/>
         </a:spcBef>
         <a:buNone/>
-        <a:defRPr sz="2700" b="1" kern="1200" baseline="0">
+        <a:defRPr sz="2000" b="1" kern="1200" baseline="0">
           <a:solidFill>
             <a:schemeClr val="tx1"/>
           </a:solidFill>
@@ -3985,16 +3985,16 @@
       </a:lvl1pPr>
     </p:titleStyle>
     <p:bodyStyle>
-      <a:lvl1pPr marL="228600" indent="-228600" algn="l" defTabSz="457200" rtl="0" eaLnBrk="1" latinLnBrk="0" hangingPunct="1">
+      <a:lvl1pPr marL="171450" indent="-171450" algn="l" defTabSz="342900" rtl="0" eaLnBrk="1" latinLnBrk="0" hangingPunct="1">
         <a:lnSpc>
           <a:spcPct val="100000"/>
         </a:lnSpc>
         <a:spcBef>
-          <a:spcPts val="800"/>
+          <a:spcPts val="600"/>
         </a:spcBef>
         <a:buFont typeface="Arial"/>
         <a:buChar char="•"/>
-        <a:defRPr sz="1600" kern="1200">
+        <a:defRPr sz="1200" kern="1200">
           <a:solidFill>
             <a:schemeClr val="tx1"/>
           </a:solidFill>
@@ -4003,16 +4003,16 @@
           <a:cs typeface="+mn-cs"/>
         </a:defRPr>
       </a:lvl1pPr>
-      <a:lvl2pPr marL="457200" indent="-228600" algn="l" defTabSz="457200" rtl="0" eaLnBrk="1" latinLnBrk="0" hangingPunct="1">
+      <a:lvl2pPr marL="342900" indent="-171450" algn="l" defTabSz="342900" rtl="0" eaLnBrk="1" latinLnBrk="0" hangingPunct="1">
         <a:lnSpc>
           <a:spcPct val="100000"/>
         </a:lnSpc>
         <a:spcBef>
-          <a:spcPts val="480"/>
+          <a:spcPts val="360"/>
         </a:spcBef>
         <a:buFont typeface="Wingdings"/>
         <a:buChar char="§"/>
-        <a:defRPr sz="1500" kern="1200">
+        <a:defRPr sz="1100" kern="1200">
           <a:solidFill>
             <a:schemeClr val="tx1"/>
           </a:solidFill>
@@ -4021,16 +4021,16 @@
           <a:cs typeface="+mn-cs"/>
         </a:defRPr>
       </a:lvl2pPr>
-      <a:lvl3pPr marL="685800" indent="-228600" algn="l" defTabSz="457200" rtl="0" eaLnBrk="1" latinLnBrk="0" hangingPunct="1">
+      <a:lvl3pPr marL="514350" indent="-171450" algn="l" defTabSz="342900" rtl="0" eaLnBrk="1" latinLnBrk="0" hangingPunct="1">
         <a:lnSpc>
           <a:spcPct val="100000"/>
         </a:lnSpc>
         <a:spcBef>
-          <a:spcPts val="480"/>
+          <a:spcPts val="360"/>
         </a:spcBef>
         <a:buFont typeface="Courier New"/>
         <a:buChar char="o"/>
-        <a:defRPr sz="1300" kern="1200">
+        <a:defRPr sz="1000" kern="1200">
           <a:solidFill>
             <a:schemeClr val="tx1"/>
           </a:solidFill>
@@ -4039,16 +4039,16 @@
           <a:cs typeface="+mn-cs"/>
         </a:defRPr>
       </a:lvl3pPr>
-      <a:lvl4pPr marL="914400" indent="-228600" algn="l" defTabSz="457200" rtl="0" eaLnBrk="1" latinLnBrk="0" hangingPunct="1">
+      <a:lvl4pPr marL="685800" indent="-171450" algn="l" defTabSz="342900" rtl="0" eaLnBrk="1" latinLnBrk="0" hangingPunct="1">
         <a:lnSpc>
           <a:spcPct val="100000"/>
         </a:lnSpc>
         <a:spcBef>
-          <a:spcPts val="480"/>
+          <a:spcPts val="360"/>
         </a:spcBef>
         <a:buFont typeface="Arial"/>
         <a:buChar char="–"/>
-        <a:defRPr sz="1200" kern="1200">
+        <a:defRPr sz="900" kern="1200">
           <a:solidFill>
             <a:schemeClr val="tx1"/>
           </a:solidFill>
@@ -4057,16 +4057,16 @@
           <a:cs typeface="+mn-cs"/>
         </a:defRPr>
       </a:lvl4pPr>
-      <a:lvl5pPr marL="1143000" indent="-228600" algn="l" defTabSz="457200" rtl="0" eaLnBrk="1" latinLnBrk="0" hangingPunct="1">
+      <a:lvl5pPr marL="857250" indent="-171450" algn="l" defTabSz="342900" rtl="0" eaLnBrk="1" latinLnBrk="0" hangingPunct="1">
         <a:lnSpc>
           <a:spcPct val="100000"/>
         </a:lnSpc>
         <a:spcBef>
-          <a:spcPts val="480"/>
+          <a:spcPts val="360"/>
         </a:spcBef>
         <a:buFont typeface="Arial"/>
         <a:buChar char="»"/>
-        <a:defRPr sz="1100" kern="1200">
+        <a:defRPr sz="800" kern="1200">
           <a:solidFill>
             <a:schemeClr val="tx1"/>
           </a:solidFill>
@@ -4075,32 +4075,32 @@
           <a:cs typeface="+mn-cs"/>
         </a:defRPr>
       </a:lvl5pPr>
-      <a:lvl6pPr marL="1371600" indent="-228600" algn="l">
-        <a:defRPr sz="1100" kern="1200">
+      <a:lvl6pPr marL="1028700" indent="-171450" algn="l">
+        <a:defRPr sz="800" kern="1200">
           <a:solidFill>
             <a:schemeClr val="tx1"/>
           </a:solidFill>
           <a:latin typeface="+mn-lt"/>
         </a:defRPr>
       </a:lvl6pPr>
-      <a:lvl7pPr marL="1600200" indent="-228600" algn="l">
-        <a:defRPr sz="1100" kern="1200">
+      <a:lvl7pPr marL="1200150" indent="-171450" algn="l">
+        <a:defRPr sz="800" kern="1200">
           <a:solidFill>
             <a:schemeClr val="tx1"/>
           </a:solidFill>
           <a:latin typeface="+mn-lt"/>
         </a:defRPr>
       </a:lvl7pPr>
-      <a:lvl8pPr marL="1828800" indent="-228600" algn="l">
-        <a:defRPr sz="1100" kern="1200">
+      <a:lvl8pPr marL="1371600" indent="-171450" algn="l">
+        <a:defRPr sz="800" kern="1200">
           <a:solidFill>
             <a:schemeClr val="tx1"/>
           </a:solidFill>
           <a:latin typeface="+mn-lt"/>
         </a:defRPr>
       </a:lvl8pPr>
-      <a:lvl9pPr marL="2057400" indent="-228600" algn="l">
-        <a:defRPr sz="1100" kern="1200">
+      <a:lvl9pPr marL="1543050" indent="-171450" algn="l">
+        <a:defRPr sz="800" kern="1200">
           <a:solidFill>
             <a:schemeClr val="tx1"/>
           </a:solidFill>
@@ -4112,8 +4112,8 @@
       <a:defPPr>
         <a:defRPr lang="en-US"/>
       </a:defPPr>
-      <a:lvl1pPr marL="0" algn="l" defTabSz="457200">
-        <a:defRPr sz="1300" kern="1200">
+      <a:lvl1pPr marL="0" algn="l" defTabSz="342900">
+        <a:defRPr sz="1000" kern="1200">
           <a:solidFill>
             <a:schemeClr val="tx1"/>
           </a:solidFill>
@@ -4122,8 +4122,8 @@
           <a:cs typeface="+mn-cs"/>
         </a:defRPr>
       </a:lvl1pPr>
-      <a:lvl2pPr marL="457200" algn="l" defTabSz="457200">
-        <a:defRPr sz="1300" kern="1200">
+      <a:lvl2pPr marL="342900" algn="l" defTabSz="342900">
+        <a:defRPr sz="1000" kern="1200">
           <a:solidFill>
             <a:schemeClr val="tx1"/>
           </a:solidFill>
@@ -4132,8 +4132,8 @@
           <a:cs typeface="+mn-cs"/>
         </a:defRPr>
       </a:lvl2pPr>
-      <a:lvl3pPr marL="914400" algn="l" defTabSz="457200">
-        <a:defRPr sz="1300" kern="1200">
+      <a:lvl3pPr marL="685800" algn="l" defTabSz="342900">
+        <a:defRPr sz="1000" kern="1200">
           <a:solidFill>
             <a:schemeClr val="tx1"/>
           </a:solidFill>
@@ -4142,8 +4142,8 @@
           <a:cs typeface="+mn-cs"/>
         </a:defRPr>
       </a:lvl3pPr>
-      <a:lvl4pPr marL="1371600" algn="l" defTabSz="457200">
-        <a:defRPr sz="1300" kern="1200">
+      <a:lvl4pPr marL="1028700" algn="l" defTabSz="342900">
+        <a:defRPr sz="1000" kern="1200">
           <a:solidFill>
             <a:schemeClr val="tx1"/>
           </a:solidFill>
@@ -4152,8 +4152,8 @@
           <a:cs typeface="+mn-cs"/>
         </a:defRPr>
       </a:lvl4pPr>
-      <a:lvl5pPr marL="1828800" algn="l" defTabSz="457200">
-        <a:defRPr sz="1300" kern="1200">
+      <a:lvl5pPr marL="1371600" algn="l" defTabSz="342900">
+        <a:defRPr sz="1000" kern="1200">
           <a:solidFill>
             <a:schemeClr val="tx1"/>
           </a:solidFill>
@@ -4162,8 +4162,8 @@
           <a:cs typeface="+mn-cs"/>
         </a:defRPr>
       </a:lvl5pPr>
-      <a:lvl6pPr marL="2286000" algn="l" defTabSz="457200">
-        <a:defRPr sz="1300" kern="1200">
+      <a:lvl6pPr marL="1714500" algn="l" defTabSz="342900">
+        <a:defRPr sz="1000" kern="1200">
           <a:solidFill>
             <a:schemeClr val="tx1"/>
           </a:solidFill>
@@ -4172,8 +4172,8 @@
           <a:cs typeface="+mn-cs"/>
         </a:defRPr>
       </a:lvl6pPr>
-      <a:lvl7pPr marL="2743200" algn="l" defTabSz="457200">
-        <a:defRPr sz="1300" kern="1200">
+      <a:lvl7pPr marL="2057400" algn="l" defTabSz="342900">
+        <a:defRPr sz="1000" kern="1200">
           <a:solidFill>
             <a:schemeClr val="tx1"/>
           </a:solidFill>
@@ -4182,8 +4182,8 @@
           <a:cs typeface="+mn-cs"/>
         </a:defRPr>
       </a:lvl7pPr>
-      <a:lvl8pPr marL="3200400" algn="l" defTabSz="457200">
-        <a:defRPr sz="1300" kern="1200">
+      <a:lvl8pPr marL="2400300" algn="l" defTabSz="342900">
+        <a:defRPr sz="1000" kern="1200">
           <a:solidFill>
             <a:schemeClr val="tx1"/>
           </a:solidFill>
@@ -4192,8 +4192,8 @@
           <a:cs typeface="+mn-cs"/>
         </a:defRPr>
       </a:lvl8pPr>
-      <a:lvl9pPr marL="3657600" algn="l" defTabSz="457200">
-        <a:defRPr sz="1300" kern="1200">
+      <a:lvl9pPr marL="2743200" algn="l" defTabSz="342900">
+        <a:defRPr sz="1000" kern="1200">
           <a:solidFill>
             <a:schemeClr val="tx1"/>
           </a:solidFill>

</xml_diff>